<commit_message>
docs: PowerPoint deck 9 slides with dashboard mockup and email
</commit_message>
<xml_diff>
--- a/PRESENTATION.pptx
+++ b/PRESENTATION.pptx
@@ -3623,7 +3623,7 @@
           <a:noFill/>
           <a:ln w="19050">
             <a:solidFill>
-              <a:srgbClr val="888888"/>
+              <a:srgbClr val="FF9900"/>
             </a:solidFill>
             <a:prstDash val="solid"/>
           </a:ln>
@@ -3669,7 +3669,7 @@
           <a:noFill/>
           <a:ln w="19050">
             <a:solidFill>
-              <a:srgbClr val="888888"/>
+              <a:srgbClr val="FF9900"/>
             </a:solidFill>
             <a:prstDash val="solid"/>
           </a:ln>
@@ -5792,6 +5792,81 @@
         </p:nvSpPr>
         <p:spPr>
           <a:xfrm>
+            <a:off x="109728" y="2450592"/>
+            <a:ext cx="1444752" cy="658368"/>
+          </a:xfrm>
+          <a:prstGeom prst="rect">
+            <a:avLst/>
+          </a:prstGeom>
+          <a:solidFill>
+            <a:srgbClr val="1A2A38"/>
+          </a:solidFill>
+          <a:ln w="12700">
+            <a:solidFill>
+              <a:srgbClr val="FF9900"/>
+            </a:solidFill>
+            <a:prstDash val="dash"/>
+          </a:ln>
+        </p:spPr>
+      </p:sp>
+      <p:sp>
+        <p:nvSpPr>
+          <p:cNvPr id="10" name="Text 8"/>
+          <p:cNvSpPr/>
+          <p:nvPr/>
+        </p:nvSpPr>
+        <p:spPr>
+          <a:xfrm>
+            <a:off x="109728" y="2450592"/>
+            <a:ext cx="1444752" cy="658368"/>
+          </a:xfrm>
+          <a:prstGeom prst="rect">
+            <a:avLst/>
+          </a:prstGeom>
+          <a:noFill/>
+          <a:ln/>
+        </p:spPr>
+        <p:txBody>
+          <a:bodyPr wrap="square" rtlCol="0" anchor="ctr"/>
+          <a:lstStyle/>
+          <a:p>
+            <a:pPr algn="ctr" indent="0" marL="0">
+              <a:buNone/>
+            </a:pPr>
+            <a:r>
+              <a:rPr lang="en-US" sz="800" dirty="0">
+                <a:solidFill>
+                  <a:srgbClr val="CCCCCC"/>
+                </a:solidFill>
+              </a:rPr>
+              <a:t>⬆ Upload CSV</a:t>
+            </a:r>
+            <a:endParaRPr lang="en-US" sz="800" dirty="0"/>
+          </a:p>
+          <a:p>
+            <a:pPr algn="ctr" indent="0" marL="0">
+              <a:buNone/>
+            </a:pPr>
+            <a:r>
+              <a:rPr lang="en-US" sz="800" dirty="0">
+                <a:solidFill>
+                  <a:srgbClr val="CCCCCC"/>
+                </a:solidFill>
+              </a:rPr>
+              <a:t>Drag &amp; Drop</a:t>
+            </a:r>
+            <a:endParaRPr lang="en-US" sz="800" dirty="0"/>
+          </a:p>
+        </p:txBody>
+      </p:sp>
+      <p:sp>
+        <p:nvSpPr>
+          <p:cNvPr id="11" name="Shape 9"/>
+          <p:cNvSpPr/>
+          <p:nvPr/>
+        </p:nvSpPr>
+        <p:spPr>
+          <a:xfrm>
             <a:off x="164592" y="4549140"/>
             <a:ext cx="502920" cy="201168"/>
           </a:xfrm>
@@ -5806,7 +5881,7 @@
       </p:sp>
       <p:sp>
         <p:nvSpPr>
-          <p:cNvPr id="10" name="Text 8"/>
+          <p:cNvPr id="12" name="Text 10"/>
           <p:cNvSpPr/>
           <p:nvPr/>
         </p:nvSpPr>
@@ -5842,7 +5917,7 @@
       </p:sp>
       <p:sp>
         <p:nvSpPr>
-          <p:cNvPr id="11" name="Text 9"/>
+          <p:cNvPr id="13" name="Text 11"/>
           <p:cNvSpPr/>
           <p:nvPr/>
         </p:nvSpPr>
@@ -5878,7 +5953,7 @@
       </p:sp>
       <p:sp>
         <p:nvSpPr>
-          <p:cNvPr id="12" name="Shape 10"/>
+          <p:cNvPr id="14" name="Shape 12"/>
           <p:cNvSpPr/>
           <p:nvPr/>
         </p:nvSpPr>
@@ -5910,7 +5985,7 @@
       </p:sp>
       <p:sp>
         <p:nvSpPr>
-          <p:cNvPr id="13" name="Text 11"/>
+          <p:cNvPr id="15" name="Text 13"/>
           <p:cNvSpPr/>
           <p:nvPr/>
         </p:nvSpPr>
@@ -5975,7 +6050,7 @@
       </p:sp>
       <p:sp>
         <p:nvSpPr>
-          <p:cNvPr id="14" name="Shape 12"/>
+          <p:cNvPr id="16" name="Shape 14"/>
           <p:cNvSpPr/>
           <p:nvPr/>
         </p:nvSpPr>
@@ -6007,7 +6082,7 @@
       </p:sp>
       <p:sp>
         <p:nvSpPr>
-          <p:cNvPr id="15" name="Text 13"/>
+          <p:cNvPr id="17" name="Text 15"/>
           <p:cNvSpPr/>
           <p:nvPr/>
         </p:nvSpPr>
@@ -6072,7 +6147,7 @@
       </p:sp>
       <p:sp>
         <p:nvSpPr>
-          <p:cNvPr id="16" name="Shape 14"/>
+          <p:cNvPr id="18" name="Shape 16"/>
           <p:cNvSpPr/>
           <p:nvPr/>
         </p:nvSpPr>
@@ -6104,7 +6179,7 @@
       </p:sp>
       <p:sp>
         <p:nvSpPr>
-          <p:cNvPr id="17" name="Text 15"/>
+          <p:cNvPr id="19" name="Text 17"/>
           <p:cNvSpPr/>
           <p:nvPr/>
         </p:nvSpPr>
@@ -6169,7 +6244,7 @@
       </p:sp>
       <p:sp>
         <p:nvSpPr>
-          <p:cNvPr id="18" name="Shape 16"/>
+          <p:cNvPr id="20" name="Shape 18"/>
           <p:cNvSpPr/>
           <p:nvPr/>
         </p:nvSpPr>
@@ -6201,7 +6276,7 @@
       </p:sp>
       <p:sp>
         <p:nvSpPr>
-          <p:cNvPr id="19" name="Text 17"/>
+          <p:cNvPr id="21" name="Text 19"/>
           <p:cNvSpPr/>
           <p:nvPr/>
         </p:nvSpPr>
@@ -6266,7 +6341,7 @@
       </p:sp>
       <p:graphicFrame>
         <p:nvGraphicFramePr>
-          <p:cNvPr id="20" name="Chart 0" descr=""/>
+          <p:cNvPr id="22" name="Chart 0" descr=""/>
           <p:cNvGraphicFramePr/>
           <p:nvPr/>
         </p:nvGraphicFramePr>
@@ -6282,7 +6357,7 @@
       </p:graphicFrame>
       <p:graphicFrame>
         <p:nvGraphicFramePr>
-          <p:cNvPr id="21" name="Chart 1" descr=""/>
+          <p:cNvPr id="23" name="Chart 1" descr=""/>
           <p:cNvGraphicFramePr/>
           <p:nvPr/>
         </p:nvGraphicFramePr>
@@ -6319,11 +6394,12 @@
             <a:tbl>
               <a:tblPr/>
               <a:tblGrid>
-                <a:gridCol w="2194560"/>
-                <a:gridCol w="1280160"/>
+                <a:gridCol w="1737360"/>
+                <a:gridCol w="1097280"/>
+                <a:gridCol w="777240"/>
+                <a:gridCol w="685800"/>
                 <a:gridCol w="914400"/>
-                <a:gridCol w="777240"/>
-                <a:gridCol w="914400"/>
+                <a:gridCol w="822960"/>
               </a:tblGrid>
               <a:tr h="320040">
                 <a:tc>
@@ -6615,7 +6691,75 @@
                           <a:ea typeface="Calibri" pitchFamily="34" charset="-122"/>
                           <a:cs typeface="Calibri" pitchFamily="34" charset="-120"/>
                         </a:rPr>
-                        <a:t>Action</a:t>
+                        <a:t>Remediate</a:t>
+                      </a:r>
+                      <a:endParaRPr lang="en-US" sz="800" dirty="0">
+                        <a:latin typeface="Calibri" charset="0"/>
+                        <a:ea typeface="Calibri" charset="0"/>
+                        <a:cs typeface="Calibri" charset="0"/>
+                      </a:endParaRPr>
+                    </a:p>
+                  </a:txBody>
+                  <a:tcPr marL="91440" marR="91440" marT="45720" marB="45720">
+                    <a:lnL w="6350" cap="flat" cmpd="sng" algn="ctr">
+                      <a:solidFill>
+                        <a:srgbClr val="CCCCCC"/>
+                      </a:solidFill>
+                      <a:prstDash val="solid"/>
+                      <a:round/>
+                      <a:headEnd type="none" w="med" len="med"/>
+                      <a:tailEnd type="none" w="med" len="med"/>
+                    </a:lnL>
+                    <a:lnR w="6350" cap="flat" cmpd="sng" algn="ctr">
+                      <a:solidFill>
+                        <a:srgbClr val="CCCCCC"/>
+                      </a:solidFill>
+                      <a:prstDash val="solid"/>
+                      <a:round/>
+                      <a:headEnd type="none" w="med" len="med"/>
+                      <a:tailEnd type="none" w="med" len="med"/>
+                    </a:lnR>
+                    <a:lnT w="6350" cap="flat" cmpd="sng" algn="ctr">
+                      <a:solidFill>
+                        <a:srgbClr val="CCCCCC"/>
+                      </a:solidFill>
+                      <a:prstDash val="solid"/>
+                      <a:round/>
+                      <a:headEnd type="none" w="med" len="med"/>
+                      <a:tailEnd type="none" w="med" len="med"/>
+                    </a:lnT>
+                    <a:lnB w="6350" cap="flat" cmpd="sng" algn="ctr">
+                      <a:solidFill>
+                        <a:srgbClr val="CCCCCC"/>
+                      </a:solidFill>
+                      <a:prstDash val="solid"/>
+                      <a:round/>
+                      <a:headEnd type="none" w="med" len="med"/>
+                      <a:tailEnd type="none" w="med" len="med"/>
+                    </a:lnB>
+                    <a:solidFill>
+                      <a:srgbClr val="232F3E"/>
+                    </a:solidFill>
+                  </a:tcPr>
+                </a:tc>
+                <a:tc>
+                  <a:txBody>
+                    <a:bodyPr/>
+                    <a:lstStyle/>
+                    <a:p>
+                      <a:pPr indent="0" marL="0">
+                        <a:buNone/>
+                      </a:pPr>
+                      <a:r>
+                        <a:rPr lang="en-US" sz="800" b="1" dirty="0">
+                          <a:solidFill>
+                            <a:srgbClr val="FFFFFF"/>
+                          </a:solidFill>
+                          <a:latin typeface="Calibri" pitchFamily="34" charset="0"/>
+                          <a:ea typeface="Calibri" pitchFamily="34" charset="-122"/>
+                          <a:cs typeface="Calibri" pitchFamily="34" charset="-120"/>
+                        </a:rPr>
+                        <a:t>Copy CLI</a:t>
                       </a:r>
                       <a:endParaRPr lang="en-US" sz="800" dirty="0">
                         <a:latin typeface="Calibri" charset="0"/>
@@ -7008,6 +7152,74 @@
                     </a:solidFill>
                   </a:tcPr>
                 </a:tc>
+                <a:tc>
+                  <a:txBody>
+                    <a:bodyPr/>
+                    <a:lstStyle/>
+                    <a:p>
+                      <a:pPr indent="0" marL="0">
+                        <a:buNone/>
+                      </a:pPr>
+                      <a:r>
+                        <a:rPr lang="en-US" sz="800" b="1" dirty="0">
+                          <a:solidFill>
+                            <a:srgbClr val="FFFFFF"/>
+                          </a:solidFill>
+                          <a:latin typeface="Calibri" pitchFamily="34" charset="0"/>
+                          <a:ea typeface="Calibri" pitchFamily="34" charset="-122"/>
+                          <a:cs typeface="Calibri" pitchFamily="34" charset="-120"/>
+                        </a:rPr>
+                        <a:t>Copy CLI</a:t>
+                      </a:r>
+                      <a:endParaRPr lang="en-US" sz="800" dirty="0">
+                        <a:latin typeface="Calibri" charset="0"/>
+                        <a:ea typeface="Calibri" charset="0"/>
+                        <a:cs typeface="Calibri" charset="0"/>
+                      </a:endParaRPr>
+                    </a:p>
+                  </a:txBody>
+                  <a:tcPr marL="91440" marR="91440" marT="45720" marB="45720">
+                    <a:lnL w="6350" cap="flat" cmpd="sng" algn="ctr">
+                      <a:solidFill>
+                        <a:srgbClr val="CCCCCC"/>
+                      </a:solidFill>
+                      <a:prstDash val="solid"/>
+                      <a:round/>
+                      <a:headEnd type="none" w="med" len="med"/>
+                      <a:tailEnd type="none" w="med" len="med"/>
+                    </a:lnL>
+                    <a:lnR w="6350" cap="flat" cmpd="sng" algn="ctr">
+                      <a:solidFill>
+                        <a:srgbClr val="CCCCCC"/>
+                      </a:solidFill>
+                      <a:prstDash val="solid"/>
+                      <a:round/>
+                      <a:headEnd type="none" w="med" len="med"/>
+                      <a:tailEnd type="none" w="med" len="med"/>
+                    </a:lnR>
+                    <a:lnT w="6350" cap="flat" cmpd="sng" algn="ctr">
+                      <a:solidFill>
+                        <a:srgbClr val="CCCCCC"/>
+                      </a:solidFill>
+                      <a:prstDash val="solid"/>
+                      <a:round/>
+                      <a:headEnd type="none" w="med" len="med"/>
+                      <a:tailEnd type="none" w="med" len="med"/>
+                    </a:lnT>
+                    <a:lnB w="6350" cap="flat" cmpd="sng" algn="ctr">
+                      <a:solidFill>
+                        <a:srgbClr val="CCCCCC"/>
+                      </a:solidFill>
+                      <a:prstDash val="solid"/>
+                      <a:round/>
+                      <a:headEnd type="none" w="med" len="med"/>
+                      <a:tailEnd type="none" w="med" len="med"/>
+                    </a:lnB>
+                    <a:solidFill>
+                      <a:srgbClr val="232F3E"/>
+                    </a:solidFill>
+                  </a:tcPr>
+                </a:tc>
               </a:tr>
               <a:tr h="320040">
                 <a:tc>
@@ -7350,6 +7562,74 @@
                     </a:solidFill>
                   </a:tcPr>
                 </a:tc>
+                <a:tc>
+                  <a:txBody>
+                    <a:bodyPr/>
+                    <a:lstStyle/>
+                    <a:p>
+                      <a:pPr indent="0" marL="0">
+                        <a:buNone/>
+                      </a:pPr>
+                      <a:r>
+                        <a:rPr lang="en-US" sz="800" b="1" dirty="0">
+                          <a:solidFill>
+                            <a:srgbClr val="FFFFFF"/>
+                          </a:solidFill>
+                          <a:latin typeface="Calibri" pitchFamily="34" charset="0"/>
+                          <a:ea typeface="Calibri" pitchFamily="34" charset="-122"/>
+                          <a:cs typeface="Calibri" pitchFamily="34" charset="-120"/>
+                        </a:rPr>
+                        <a:t>Copy CLI</a:t>
+                      </a:r>
+                      <a:endParaRPr lang="en-US" sz="800" dirty="0">
+                        <a:latin typeface="Calibri" charset="0"/>
+                        <a:ea typeface="Calibri" charset="0"/>
+                        <a:cs typeface="Calibri" charset="0"/>
+                      </a:endParaRPr>
+                    </a:p>
+                  </a:txBody>
+                  <a:tcPr marL="91440" marR="91440" marT="45720" marB="45720">
+                    <a:lnL w="6350" cap="flat" cmpd="sng" algn="ctr">
+                      <a:solidFill>
+                        <a:srgbClr val="CCCCCC"/>
+                      </a:solidFill>
+                      <a:prstDash val="solid"/>
+                      <a:round/>
+                      <a:headEnd type="none" w="med" len="med"/>
+                      <a:tailEnd type="none" w="med" len="med"/>
+                    </a:lnL>
+                    <a:lnR w="6350" cap="flat" cmpd="sng" algn="ctr">
+                      <a:solidFill>
+                        <a:srgbClr val="CCCCCC"/>
+                      </a:solidFill>
+                      <a:prstDash val="solid"/>
+                      <a:round/>
+                      <a:headEnd type="none" w="med" len="med"/>
+                      <a:tailEnd type="none" w="med" len="med"/>
+                    </a:lnR>
+                    <a:lnT w="6350" cap="flat" cmpd="sng" algn="ctr">
+                      <a:solidFill>
+                        <a:srgbClr val="CCCCCC"/>
+                      </a:solidFill>
+                      <a:prstDash val="solid"/>
+                      <a:round/>
+                      <a:headEnd type="none" w="med" len="med"/>
+                      <a:tailEnd type="none" w="med" len="med"/>
+                    </a:lnT>
+                    <a:lnB w="6350" cap="flat" cmpd="sng" algn="ctr">
+                      <a:solidFill>
+                        <a:srgbClr val="CCCCCC"/>
+                      </a:solidFill>
+                      <a:prstDash val="solid"/>
+                      <a:round/>
+                      <a:headEnd type="none" w="med" len="med"/>
+                      <a:tailEnd type="none" w="med" len="med"/>
+                    </a:lnB>
+                    <a:solidFill>
+                      <a:srgbClr val="232F3E"/>
+                    </a:solidFill>
+                  </a:tcPr>
+                </a:tc>
               </a:tr>
               <a:tr h="320040">
                 <a:tc>
@@ -7692,6 +7972,74 @@
                     </a:solidFill>
                   </a:tcPr>
                 </a:tc>
+                <a:tc>
+                  <a:txBody>
+                    <a:bodyPr/>
+                    <a:lstStyle/>
+                    <a:p>
+                      <a:pPr indent="0" marL="0">
+                        <a:buNone/>
+                      </a:pPr>
+                      <a:r>
+                        <a:rPr lang="en-US" sz="800" b="1" dirty="0">
+                          <a:solidFill>
+                            <a:srgbClr val="FFFFFF"/>
+                          </a:solidFill>
+                          <a:latin typeface="Calibri" pitchFamily="34" charset="0"/>
+                          <a:ea typeface="Calibri" pitchFamily="34" charset="-122"/>
+                          <a:cs typeface="Calibri" pitchFamily="34" charset="-120"/>
+                        </a:rPr>
+                        <a:t>Copy CLI</a:t>
+                      </a:r>
+                      <a:endParaRPr lang="en-US" sz="800" dirty="0">
+                        <a:latin typeface="Calibri" charset="0"/>
+                        <a:ea typeface="Calibri" charset="0"/>
+                        <a:cs typeface="Calibri" charset="0"/>
+                      </a:endParaRPr>
+                    </a:p>
+                  </a:txBody>
+                  <a:tcPr marL="91440" marR="91440" marT="45720" marB="45720">
+                    <a:lnL w="6350" cap="flat" cmpd="sng" algn="ctr">
+                      <a:solidFill>
+                        <a:srgbClr val="CCCCCC"/>
+                      </a:solidFill>
+                      <a:prstDash val="solid"/>
+                      <a:round/>
+                      <a:headEnd type="none" w="med" len="med"/>
+                      <a:tailEnd type="none" w="med" len="med"/>
+                    </a:lnL>
+                    <a:lnR w="6350" cap="flat" cmpd="sng" algn="ctr">
+                      <a:solidFill>
+                        <a:srgbClr val="CCCCCC"/>
+                      </a:solidFill>
+                      <a:prstDash val="solid"/>
+                      <a:round/>
+                      <a:headEnd type="none" w="med" len="med"/>
+                      <a:tailEnd type="none" w="med" len="med"/>
+                    </a:lnR>
+                    <a:lnT w="6350" cap="flat" cmpd="sng" algn="ctr">
+                      <a:solidFill>
+                        <a:srgbClr val="CCCCCC"/>
+                      </a:solidFill>
+                      <a:prstDash val="solid"/>
+                      <a:round/>
+                      <a:headEnd type="none" w="med" len="med"/>
+                      <a:tailEnd type="none" w="med" len="med"/>
+                    </a:lnT>
+                    <a:lnB w="6350" cap="flat" cmpd="sng" algn="ctr">
+                      <a:solidFill>
+                        <a:srgbClr val="CCCCCC"/>
+                      </a:solidFill>
+                      <a:prstDash val="solid"/>
+                      <a:round/>
+                      <a:headEnd type="none" w="med" len="med"/>
+                      <a:tailEnd type="none" w="med" len="med"/>
+                    </a:lnB>
+                    <a:solidFill>
+                      <a:srgbClr val="232F3E"/>
+                    </a:solidFill>
+                  </a:tcPr>
+                </a:tc>
               </a:tr>
             </a:tbl>
           </a:graphicData>
@@ -7699,7 +8047,7 @@
       </p:graphicFrame>
       <p:sp>
         <p:nvSpPr>
-          <p:cNvPr id="23" name="Text 18"/>
+          <p:cNvPr id="25" name="Text 20"/>
           <p:cNvSpPr/>
           <p:nvPr/>
         </p:nvSpPr>
@@ -7730,7 +8078,7 @@
                 <a:ea typeface="Calibri" pitchFamily="34" charset="-122"/>
                 <a:cs typeface="Calibri" pitchFamily="34" charset="-120"/>
               </a:rPr>
-              <a:t>Admin sees the Remediate button — executes directly on AWS using admin credentials</a:t>
+              <a:t>Admin: Upload CSV · Ingest · Remediate via AWS API · Copy CLI command</a:t>
             </a:r>
             <a:endParaRPr lang="en-US" sz="750" dirty="0"/>
           </a:p>
@@ -7738,7 +8086,7 @@
       </p:sp>
       <p:sp>
         <p:nvSpPr>
-          <p:cNvPr id="24" name="Shape 19"/>
+          <p:cNvPr id="26" name="Shape 21"/>
           <p:cNvSpPr/>
           <p:nvPr/>
         </p:nvSpPr>
@@ -7763,7 +8111,7 @@
       </p:sp>
       <p:sp>
         <p:nvSpPr>
-          <p:cNvPr id="25" name="Text 20"/>
+          <p:cNvPr id="27" name="Text 22"/>
           <p:cNvSpPr/>
           <p:nvPr/>
         </p:nvSpPr>
@@ -7799,7 +8147,7 @@
       </p:sp>
       <p:sp>
         <p:nvSpPr>
-          <p:cNvPr id="26" name="Text 21"/>
+          <p:cNvPr id="28" name="Text 23"/>
           <p:cNvSpPr/>
           <p:nvPr/>
         </p:nvSpPr>
@@ -8035,6 +8383,81 @@
         </p:nvSpPr>
         <p:spPr>
           <a:xfrm>
+            <a:off x="109728" y="1737360"/>
+            <a:ext cx="1444752" cy="658368"/>
+          </a:xfrm>
+          <a:prstGeom prst="rect">
+            <a:avLst/>
+          </a:prstGeom>
+          <a:solidFill>
+            <a:srgbClr val="1A2A38"/>
+          </a:solidFill>
+          <a:ln w="12700">
+            <a:solidFill>
+              <a:srgbClr val="CCCCCC"/>
+            </a:solidFill>
+            <a:prstDash val="dash"/>
+          </a:ln>
+        </p:spPr>
+      </p:sp>
+      <p:sp>
+        <p:nvSpPr>
+          <p:cNvPr id="8" name="Text 6"/>
+          <p:cNvSpPr/>
+          <p:nvPr/>
+        </p:nvSpPr>
+        <p:spPr>
+          <a:xfrm>
+            <a:off x="109728" y="1737360"/>
+            <a:ext cx="1444752" cy="658368"/>
+          </a:xfrm>
+          <a:prstGeom prst="rect">
+            <a:avLst/>
+          </a:prstGeom>
+          <a:noFill/>
+          <a:ln/>
+        </p:spPr>
+        <p:txBody>
+          <a:bodyPr wrap="square" rtlCol="0" anchor="ctr"/>
+          <a:lstStyle/>
+          <a:p>
+            <a:pPr algn="ctr" indent="0" marL="0">
+              <a:buNone/>
+            </a:pPr>
+            <a:r>
+              <a:rPr lang="en-US" sz="800" dirty="0">
+                <a:solidFill>
+                  <a:srgbClr val="CCCCCC"/>
+                </a:solidFill>
+              </a:rPr>
+              <a:t>⬆ Upload CSV</a:t>
+            </a:r>
+            <a:endParaRPr lang="en-US" sz="800" dirty="0"/>
+          </a:p>
+          <a:p>
+            <a:pPr algn="ctr" indent="0" marL="0">
+              <a:buNone/>
+            </a:pPr>
+            <a:r>
+              <a:rPr lang="en-US" sz="800" dirty="0">
+                <a:solidFill>
+                  <a:srgbClr val="CCCCCC"/>
+                </a:solidFill>
+              </a:rPr>
+              <a:t>Drag &amp; Drop</a:t>
+            </a:r>
+            <a:endParaRPr lang="en-US" sz="800" dirty="0"/>
+          </a:p>
+        </p:txBody>
+      </p:sp>
+      <p:sp>
+        <p:nvSpPr>
+          <p:cNvPr id="9" name="Shape 7"/>
+          <p:cNvSpPr/>
+          <p:nvPr/>
+        </p:nvSpPr>
+        <p:spPr>
+          <a:xfrm>
             <a:off x="164592" y="4549140"/>
             <a:ext cx="502920" cy="201168"/>
           </a:xfrm>
@@ -8049,7 +8472,7 @@
       </p:sp>
       <p:sp>
         <p:nvSpPr>
-          <p:cNvPr id="8" name="Text 6"/>
+          <p:cNvPr id="10" name="Text 8"/>
           <p:cNvSpPr/>
           <p:nvPr/>
         </p:nvSpPr>
@@ -8085,7 +8508,7 @@
       </p:sp>
       <p:sp>
         <p:nvSpPr>
-          <p:cNvPr id="9" name="Text 7"/>
+          <p:cNvPr id="11" name="Text 9"/>
           <p:cNvSpPr/>
           <p:nvPr/>
         </p:nvSpPr>
@@ -8121,7 +8544,7 @@
       </p:sp>
       <p:sp>
         <p:nvSpPr>
-          <p:cNvPr id="10" name="Shape 8"/>
+          <p:cNvPr id="12" name="Shape 10"/>
           <p:cNvSpPr/>
           <p:nvPr/>
         </p:nvSpPr>
@@ -8153,7 +8576,7 @@
       </p:sp>
       <p:sp>
         <p:nvSpPr>
-          <p:cNvPr id="11" name="Text 9"/>
+          <p:cNvPr id="13" name="Text 11"/>
           <p:cNvSpPr/>
           <p:nvPr/>
         </p:nvSpPr>
@@ -8218,7 +8641,7 @@
       </p:sp>
       <p:sp>
         <p:nvSpPr>
-          <p:cNvPr id="12" name="Shape 10"/>
+          <p:cNvPr id="14" name="Shape 12"/>
           <p:cNvSpPr/>
           <p:nvPr/>
         </p:nvSpPr>
@@ -8250,7 +8673,7 @@
       </p:sp>
       <p:sp>
         <p:nvSpPr>
-          <p:cNvPr id="13" name="Text 11"/>
+          <p:cNvPr id="15" name="Text 13"/>
           <p:cNvSpPr/>
           <p:nvPr/>
         </p:nvSpPr>
@@ -8315,7 +8738,7 @@
       </p:sp>
       <p:sp>
         <p:nvSpPr>
-          <p:cNvPr id="14" name="Shape 12"/>
+          <p:cNvPr id="16" name="Shape 14"/>
           <p:cNvSpPr/>
           <p:nvPr/>
         </p:nvSpPr>
@@ -8347,7 +8770,7 @@
       </p:sp>
       <p:sp>
         <p:nvSpPr>
-          <p:cNvPr id="15" name="Text 13"/>
+          <p:cNvPr id="17" name="Text 15"/>
           <p:cNvSpPr/>
           <p:nvPr/>
         </p:nvSpPr>
@@ -8412,7 +8835,7 @@
       </p:sp>
       <p:sp>
         <p:nvSpPr>
-          <p:cNvPr id="16" name="Shape 14"/>
+          <p:cNvPr id="18" name="Shape 16"/>
           <p:cNvSpPr/>
           <p:nvPr/>
         </p:nvSpPr>
@@ -8444,7 +8867,7 @@
       </p:sp>
       <p:sp>
         <p:nvSpPr>
-          <p:cNvPr id="17" name="Text 15"/>
+          <p:cNvPr id="19" name="Text 17"/>
           <p:cNvSpPr/>
           <p:nvPr/>
         </p:nvSpPr>
@@ -8509,7 +8932,7 @@
       </p:sp>
       <p:sp>
         <p:nvSpPr>
-          <p:cNvPr id="18" name="Shape 16"/>
+          <p:cNvPr id="20" name="Shape 18"/>
           <p:cNvSpPr/>
           <p:nvPr/>
         </p:nvSpPr>
@@ -8534,7 +8957,7 @@
       </p:sp>
       <p:sp>
         <p:nvSpPr>
-          <p:cNvPr id="19" name="Text 17"/>
+          <p:cNvPr id="21" name="Text 19"/>
           <p:cNvSpPr/>
           <p:nvPr/>
         </p:nvSpPr>
@@ -9971,7 +10394,7 @@
       </p:graphicFrame>
       <p:sp>
         <p:nvSpPr>
-          <p:cNvPr id="21" name="Text 18"/>
+          <p:cNvPr id="23" name="Text 20"/>
           <p:cNvSpPr/>
           <p:nvPr/>
         </p:nvSpPr>
@@ -10002,7 +10425,7 @@
                 <a:ea typeface="Calibri" pitchFamily="34" charset="-122"/>
                 <a:cs typeface="Calibri" pitchFamily="34" charset="-120"/>
               </a:rPr>
-              <a:t>Viewer copies the CLI command and runs it manually in AWS Console or terminal</a:t>
+              <a:t>Viewer: Upload CSV · Ingest · Copy CLI command — no remediation access</a:t>
             </a:r>
             <a:endParaRPr lang="en-US" sz="750" dirty="0"/>
           </a:p>
@@ -10010,7 +10433,7 @@
       </p:sp>
       <p:sp>
         <p:nvSpPr>
-          <p:cNvPr id="22" name="Shape 19"/>
+          <p:cNvPr id="24" name="Shape 21"/>
           <p:cNvSpPr/>
           <p:nvPr/>
         </p:nvSpPr>
@@ -10035,7 +10458,7 @@
       </p:sp>
       <p:sp>
         <p:nvSpPr>
-          <p:cNvPr id="23" name="Text 20"/>
+          <p:cNvPr id="25" name="Text 22"/>
           <p:cNvSpPr/>
           <p:nvPr/>
         </p:nvSpPr>
@@ -10071,7 +10494,7 @@
       </p:sp>
       <p:sp>
         <p:nvSpPr>
-          <p:cNvPr id="24" name="Text 21"/>
+          <p:cNvPr id="26" name="Text 23"/>
           <p:cNvSpPr/>
           <p:nvPr/>
         </p:nvSpPr>

</xml_diff>